<commit_message>
feat(pptx): add natural AI photos and visual diagrams to slides 2, 5, 7, 8, 9
</commit_message>
<xml_diff>
--- a/Elcan_Seferli_6326A2_Serbest_Is.pptx
+++ b/Elcan_Seferli_6326A2_Serbest_Is.pptx
@@ -3859,8 +3859,8 @@
         </p:nvSpPr>
         <p:spPr>
           <a:xfrm>
-            <a:off x="731520" y="1417320"/>
-            <a:ext cx="10698480" cy="685800"/>
+            <a:off x="731520" y="1371600"/>
+            <a:ext cx="10698480" cy="640080"/>
           </a:xfrm>
           <a:prstGeom prst="rect">
             <a:avLst/>
@@ -3874,7 +3874,7 @@
           <a:lstStyle/>
           <a:p>
             <a:pPr>
-              <a:defRPr sz="1800">
+              <a:defRPr sz="1750">
                 <a:solidFill>
                   <a:srgbClr val="64748B"/>
                 </a:solidFill>
@@ -3895,8 +3895,8 @@
         </p:nvSpPr>
         <p:spPr>
           <a:xfrm>
-            <a:off x="731520" y="2148840"/>
-            <a:ext cx="10698480" cy="4114800"/>
+            <a:off x="731520" y="2084831"/>
+            <a:ext cx="6263640" cy="4224528"/>
           </a:xfrm>
           <a:prstGeom prst="roundRect">
             <a:avLst>
@@ -3942,8 +3942,8 @@
         </p:nvSpPr>
         <p:spPr>
           <a:xfrm>
-            <a:off x="1005840" y="2377440"/>
-            <a:ext cx="10149840" cy="3657600"/>
+            <a:off x="960120" y="2267712"/>
+            <a:ext cx="5806440" cy="3886200"/>
           </a:xfrm>
           <a:prstGeom prst="rect">
             <a:avLst/>
@@ -3958,9 +3958,9 @@
           <a:p>
             <a:pPr>
               <a:spcAft>
-                <a:spcPts val="1400"/>
+                <a:spcPts val="1300"/>
               </a:spcAft>
-              <a:defRPr sz="1800">
+              <a:defRPr sz="1750">
                 <a:solidFill>
                   <a:srgbClr val="1E293B"/>
                 </a:solidFill>
@@ -3974,9 +3974,9 @@
           <a:p>
             <a:pPr>
               <a:spcAft>
-                <a:spcPts val="1400"/>
+                <a:spcPts val="1300"/>
               </a:spcAft>
-              <a:defRPr sz="1800">
+              <a:defRPr sz="1750">
                 <a:solidFill>
                   <a:srgbClr val="1E293B"/>
                 </a:solidFill>
@@ -3990,9 +3990,9 @@
           <a:p>
             <a:pPr>
               <a:spcAft>
-                <a:spcPts val="1400"/>
+                <a:spcPts val="1300"/>
               </a:spcAft>
-              <a:defRPr sz="1800">
+              <a:defRPr sz="1750">
                 <a:solidFill>
                   <a:srgbClr val="1E293B"/>
                 </a:solidFill>
@@ -4006,9 +4006,9 @@
           <a:p>
             <a:pPr>
               <a:spcAft>
-                <a:spcPts val="1400"/>
+                <a:spcPts val="1300"/>
               </a:spcAft>
-              <a:defRPr sz="1800">
+              <a:defRPr sz="1750">
                 <a:solidFill>
                   <a:srgbClr val="1E293B"/>
                 </a:solidFill>
@@ -4017,6 +4017,113 @@
             </a:pPr>
             <a:r>
               <a:t>•  Əsas məqsədi idarəetməni sürətləndirmək, bürokratiyanı və kağız sərfiyyatını azaltmaqdır.</a:t>
+            </a:r>
+          </a:p>
+        </p:txBody>
+      </p:sp>
+      <p:sp>
+        <p:nvSpPr>
+          <p:cNvPr id="8" name="Rounded Rectangle 7"/>
+          <p:cNvSpPr/>
+          <p:nvPr/>
+        </p:nvSpPr>
+        <p:spPr>
+          <a:xfrm>
+            <a:off x="7223760" y="2084831"/>
+            <a:ext cx="4206240" cy="4224528"/>
+          </a:xfrm>
+          <a:prstGeom prst="roundRect">
+            <a:avLst>
+              <a:gd name="adj" fmla="val 2000"/>
+            </a:avLst>
+          </a:prstGeom>
+          <a:solidFill>
+            <a:srgbClr val="F8FAFC"/>
+          </a:solidFill>
+          <a:ln>
+            <a:solidFill>
+              <a:srgbClr val="CBD5E1"/>
+            </a:solidFill>
+          </a:ln>
+        </p:spPr>
+        <p:style>
+          <a:lnRef idx="1">
+            <a:schemeClr val="accent1"/>
+          </a:lnRef>
+          <a:fillRef idx="3">
+            <a:schemeClr val="accent1"/>
+          </a:fillRef>
+          <a:effectRef idx="2">
+            <a:schemeClr val="accent1"/>
+          </a:effectRef>
+          <a:fontRef idx="minor">
+            <a:schemeClr val="lt1"/>
+          </a:fontRef>
+        </p:style>
+        <p:txBody>
+          <a:bodyPr rtlCol="0" anchor="ctr"/>
+          <a:lstStyle/>
+          <a:p>
+            <a:pPr algn="ctr"/>
+          </a:p>
+        </p:txBody>
+      </p:sp>
+      <p:pic>
+        <p:nvPicPr>
+          <p:cNvPr id="9" name="Picture 8" descr="slide2_elektron_sened_1790802721453.jpg"/>
+          <p:cNvPicPr>
+            <a:picLocks noChangeAspect="1"/>
+          </p:cNvPicPr>
+          <p:nvPr/>
+        </p:nvPicPr>
+        <p:blipFill>
+          <a:blip r:embed="rId2"/>
+          <a:stretch>
+            <a:fillRect/>
+          </a:stretch>
+        </p:blipFill>
+        <p:spPr>
+          <a:xfrm>
+            <a:off x="7360920" y="2240280"/>
+            <a:ext cx="3931920" cy="2935834"/>
+          </a:xfrm>
+          <a:prstGeom prst="rect">
+            <a:avLst/>
+          </a:prstGeom>
+        </p:spPr>
+      </p:pic>
+      <p:sp>
+        <p:nvSpPr>
+          <p:cNvPr id="10" name="TextBox 9"/>
+          <p:cNvSpPr txBox="1"/>
+          <p:nvPr/>
+        </p:nvSpPr>
+        <p:spPr>
+          <a:xfrm>
+            <a:off x="7360920" y="5321808"/>
+            <a:ext cx="3931920" cy="731520"/>
+          </a:xfrm>
+          <a:prstGeom prst="rect">
+            <a:avLst/>
+          </a:prstGeom>
+          <a:noFill/>
+        </p:spPr>
+        <p:txBody>
+          <a:bodyPr wrap="square">
+            <a:spAutoFit/>
+          </a:bodyPr>
+          <a:lstStyle/>
+          <a:p>
+            <a:pPr algn="ctr">
+              <a:defRPr sz="1400" i="1">
+                <a:solidFill>
+                  <a:srgbClr val="64748B"/>
+                </a:solidFill>
+                <a:latin typeface="Calibri"/>
+              </a:defRPr>
+            </a:pPr>
+            <a:r>
+              <a:t>Rəqəmsal və kağız sənədlərin müqayisəsi</a:t>
             </a:r>
           </a:p>
         </p:txBody>
@@ -4169,8 +4276,8 @@
         </p:nvSpPr>
         <p:spPr>
           <a:xfrm>
-            <a:off x="731520" y="1417320"/>
-            <a:ext cx="10698480" cy="685800"/>
+            <a:off x="731520" y="1371600"/>
+            <a:ext cx="10698480" cy="640080"/>
           </a:xfrm>
           <a:prstGeom prst="rect">
             <a:avLst/>
@@ -4184,7 +4291,7 @@
           <a:lstStyle/>
           <a:p>
             <a:pPr>
-              <a:defRPr sz="1800">
+              <a:defRPr sz="1750">
                 <a:solidFill>
                   <a:srgbClr val="64748B"/>
                 </a:solidFill>
@@ -4205,8 +4312,8 @@
         </p:nvSpPr>
         <p:spPr>
           <a:xfrm>
-            <a:off x="731520" y="2148840"/>
-            <a:ext cx="10698480" cy="4114800"/>
+            <a:off x="731520" y="2084831"/>
+            <a:ext cx="10698480" cy="4224528"/>
           </a:xfrm>
           <a:prstGeom prst="roundRect">
             <a:avLst>
@@ -4252,8 +4359,8 @@
         </p:nvSpPr>
         <p:spPr>
           <a:xfrm>
-            <a:off x="1005840" y="2377440"/>
-            <a:ext cx="10149840" cy="3657600"/>
+            <a:off x="960120" y="2267712"/>
+            <a:ext cx="10149840" cy="3886200"/>
           </a:xfrm>
           <a:prstGeom prst="rect">
             <a:avLst/>
@@ -4268,7 +4375,7 @@
           <a:p>
             <a:pPr>
               <a:spcAft>
-                <a:spcPts val="1400"/>
+                <a:spcPts val="1300"/>
               </a:spcAft>
               <a:defRPr sz="1800">
                 <a:solidFill>
@@ -4284,7 +4391,7 @@
           <a:p>
             <a:pPr>
               <a:spcAft>
-                <a:spcPts val="1400"/>
+                <a:spcPts val="1300"/>
               </a:spcAft>
               <a:defRPr sz="1800">
                 <a:solidFill>
@@ -4300,7 +4407,7 @@
           <a:p>
             <a:pPr>
               <a:spcAft>
-                <a:spcPts val="1400"/>
+                <a:spcPts val="1300"/>
               </a:spcAft>
               <a:defRPr sz="1800">
                 <a:solidFill>
@@ -4316,7 +4423,7 @@
           <a:p>
             <a:pPr>
               <a:spcAft>
-                <a:spcPts val="1400"/>
+                <a:spcPts val="1300"/>
               </a:spcAft>
               <a:defRPr sz="1800">
                 <a:solidFill>
@@ -4332,7 +4439,7 @@
           <a:p>
             <a:pPr>
               <a:spcAft>
-                <a:spcPts val="1400"/>
+                <a:spcPts val="1300"/>
               </a:spcAft>
               <a:defRPr sz="1800">
                 <a:solidFill>
@@ -4935,8 +5042,8 @@
         </p:nvSpPr>
         <p:spPr>
           <a:xfrm>
-            <a:off x="731520" y="1417320"/>
-            <a:ext cx="10698480" cy="685800"/>
+            <a:off x="731520" y="1371600"/>
+            <a:ext cx="10698480" cy="640080"/>
           </a:xfrm>
           <a:prstGeom prst="rect">
             <a:avLst/>
@@ -4950,7 +5057,7 @@
           <a:lstStyle/>
           <a:p>
             <a:pPr>
-              <a:defRPr sz="1800">
+              <a:defRPr sz="1750">
                 <a:solidFill>
                   <a:srgbClr val="64748B"/>
                 </a:solidFill>
@@ -4971,8 +5078,8 @@
         </p:nvSpPr>
         <p:spPr>
           <a:xfrm>
-            <a:off x="731520" y="2148840"/>
-            <a:ext cx="10698480" cy="4114800"/>
+            <a:off x="731520" y="2084831"/>
+            <a:ext cx="6263640" cy="4224528"/>
           </a:xfrm>
           <a:prstGeom prst="roundRect">
             <a:avLst>
@@ -5018,8 +5125,8 @@
         </p:nvSpPr>
         <p:spPr>
           <a:xfrm>
-            <a:off x="1005840" y="2377440"/>
-            <a:ext cx="10149840" cy="3657600"/>
+            <a:off x="960120" y="2267712"/>
+            <a:ext cx="5806440" cy="3886200"/>
           </a:xfrm>
           <a:prstGeom prst="rect">
             <a:avLst/>
@@ -5034,9 +5141,9 @@
           <a:p>
             <a:pPr>
               <a:spcAft>
-                <a:spcPts val="1400"/>
+                <a:spcPts val="1000"/>
               </a:spcAft>
-              <a:defRPr sz="1800">
+              <a:defRPr sz="1650">
                 <a:solidFill>
                   <a:srgbClr val="1E293B"/>
                 </a:solidFill>
@@ -5050,9 +5157,9 @@
           <a:p>
             <a:pPr>
               <a:spcAft>
-                <a:spcPts val="1400"/>
+                <a:spcPts val="1000"/>
               </a:spcAft>
-              <a:defRPr sz="1800">
+              <a:defRPr sz="1650">
                 <a:solidFill>
                   <a:srgbClr val="1E293B"/>
                 </a:solidFill>
@@ -5066,9 +5173,9 @@
           <a:p>
             <a:pPr>
               <a:spcAft>
-                <a:spcPts val="1400"/>
+                <a:spcPts val="1000"/>
               </a:spcAft>
-              <a:defRPr sz="1800">
+              <a:defRPr sz="1650">
                 <a:solidFill>
                   <a:srgbClr val="1E293B"/>
                 </a:solidFill>
@@ -5082,9 +5189,9 @@
           <a:p>
             <a:pPr>
               <a:spcAft>
-                <a:spcPts val="1400"/>
+                <a:spcPts val="1000"/>
               </a:spcAft>
-              <a:defRPr sz="1800">
+              <a:defRPr sz="1650">
                 <a:solidFill>
                   <a:srgbClr val="1E293B"/>
                 </a:solidFill>
@@ -5098,9 +5205,9 @@
           <a:p>
             <a:pPr>
               <a:spcAft>
-                <a:spcPts val="1400"/>
+                <a:spcPts val="1000"/>
               </a:spcAft>
-              <a:defRPr sz="1800">
+              <a:defRPr sz="1650">
                 <a:solidFill>
                   <a:srgbClr val="1E293B"/>
                 </a:solidFill>
@@ -5114,9 +5221,9 @@
           <a:p>
             <a:pPr>
               <a:spcAft>
-                <a:spcPts val="1400"/>
+                <a:spcPts val="1000"/>
               </a:spcAft>
-              <a:defRPr sz="1800">
+              <a:defRPr sz="1650">
                 <a:solidFill>
                   <a:srgbClr val="1E293B"/>
                 </a:solidFill>
@@ -5125,6 +5232,113 @@
             </a:pPr>
             <a:r>
               <a:t>6. İmza hissəsi — sənədi hazırlayan və ya təsdiqləyən şəxsin vəzifəsi, adı və elektron imzası.</a:t>
+            </a:r>
+          </a:p>
+        </p:txBody>
+      </p:sp>
+      <p:sp>
+        <p:nvSpPr>
+          <p:cNvPr id="8" name="Rounded Rectangle 7"/>
+          <p:cNvSpPr/>
+          <p:nvPr/>
+        </p:nvSpPr>
+        <p:spPr>
+          <a:xfrm>
+            <a:off x="7223760" y="2084831"/>
+            <a:ext cx="4206240" cy="4224528"/>
+          </a:xfrm>
+          <a:prstGeom prst="roundRect">
+            <a:avLst>
+              <a:gd name="adj" fmla="val 2000"/>
+            </a:avLst>
+          </a:prstGeom>
+          <a:solidFill>
+            <a:srgbClr val="F8FAFC"/>
+          </a:solidFill>
+          <a:ln>
+            <a:solidFill>
+              <a:srgbClr val="CBD5E1"/>
+            </a:solidFill>
+          </a:ln>
+        </p:spPr>
+        <p:style>
+          <a:lnRef idx="1">
+            <a:schemeClr val="accent1"/>
+          </a:lnRef>
+          <a:fillRef idx="3">
+            <a:schemeClr val="accent1"/>
+          </a:fillRef>
+          <a:effectRef idx="2">
+            <a:schemeClr val="accent1"/>
+          </a:effectRef>
+          <a:fontRef idx="minor">
+            <a:schemeClr val="lt1"/>
+          </a:fontRef>
+        </p:style>
+        <p:txBody>
+          <a:bodyPr rtlCol="0" anchor="ctr"/>
+          <a:lstStyle/>
+          <a:p>
+            <a:pPr algn="ctr"/>
+          </a:p>
+        </p:txBody>
+      </p:sp>
+      <p:pic>
+        <p:nvPicPr>
+          <p:cNvPr id="9" name="Picture 8" descr="slide5_sened_hazirlanmasi_1790802754301.jpg"/>
+          <p:cNvPicPr>
+            <a:picLocks noChangeAspect="1"/>
+          </p:cNvPicPr>
+          <p:nvPr/>
+        </p:nvPicPr>
+        <p:blipFill>
+          <a:blip r:embed="rId2"/>
+          <a:stretch>
+            <a:fillRect/>
+          </a:stretch>
+        </p:blipFill>
+        <p:spPr>
+          <a:xfrm>
+            <a:off x="7360920" y="2240280"/>
+            <a:ext cx="3931920" cy="2935834"/>
+          </a:xfrm>
+          <a:prstGeom prst="rect">
+            <a:avLst/>
+          </a:prstGeom>
+        </p:spPr>
+      </p:pic>
+      <p:sp>
+        <p:nvSpPr>
+          <p:cNvPr id="10" name="TextBox 9"/>
+          <p:cNvSpPr txBox="1"/>
+          <p:nvPr/>
+        </p:nvSpPr>
+        <p:spPr>
+          <a:xfrm>
+            <a:off x="7360920" y="5321808"/>
+            <a:ext cx="3931920" cy="731520"/>
+          </a:xfrm>
+          <a:prstGeom prst="rect">
+            <a:avLst/>
+          </a:prstGeom>
+          <a:noFill/>
+        </p:spPr>
+        <p:txBody>
+          <a:bodyPr wrap="square">
+            <a:spAutoFit/>
+          </a:bodyPr>
+          <a:lstStyle/>
+          <a:p>
+            <a:pPr algn="ctr">
+              <a:defRPr sz="1400" i="1">
+                <a:solidFill>
+                  <a:srgbClr val="64748B"/>
+                </a:solidFill>
+                <a:latin typeface="Calibri"/>
+              </a:defRPr>
+            </a:pPr>
+            <a:r>
+              <a:t>Rəsmi sənədin elektron tərtibi prosesi</a:t>
             </a:r>
           </a:p>
         </p:txBody>
@@ -5277,8 +5491,8 @@
         </p:nvSpPr>
         <p:spPr>
           <a:xfrm>
-            <a:off x="731520" y="1417320"/>
-            <a:ext cx="10698480" cy="685800"/>
+            <a:off x="731520" y="1371600"/>
+            <a:ext cx="10698480" cy="640080"/>
           </a:xfrm>
           <a:prstGeom prst="rect">
             <a:avLst/>
@@ -5292,7 +5506,7 @@
           <a:lstStyle/>
           <a:p>
             <a:pPr>
-              <a:defRPr sz="1800">
+              <a:defRPr sz="1750">
                 <a:solidFill>
                   <a:srgbClr val="64748B"/>
                 </a:solidFill>
@@ -5313,8 +5527,8 @@
         </p:nvSpPr>
         <p:spPr>
           <a:xfrm>
-            <a:off x="731520" y="2148840"/>
-            <a:ext cx="10698480" cy="4114800"/>
+            <a:off x="731520" y="2084831"/>
+            <a:ext cx="10698480" cy="4224528"/>
           </a:xfrm>
           <a:prstGeom prst="roundRect">
             <a:avLst>
@@ -5360,8 +5574,8 @@
         </p:nvSpPr>
         <p:spPr>
           <a:xfrm>
-            <a:off x="1005840" y="2377440"/>
-            <a:ext cx="10149840" cy="3657600"/>
+            <a:off x="960120" y="2267712"/>
+            <a:ext cx="10149840" cy="3886200"/>
           </a:xfrm>
           <a:prstGeom prst="rect">
             <a:avLst/>
@@ -5376,7 +5590,7 @@
           <a:p>
             <a:pPr>
               <a:spcAft>
-                <a:spcPts val="1400"/>
+                <a:spcPts val="1300"/>
               </a:spcAft>
               <a:defRPr sz="1800">
                 <a:solidFill>
@@ -5392,7 +5606,7 @@
           <a:p>
             <a:pPr>
               <a:spcAft>
-                <a:spcPts val="1400"/>
+                <a:spcPts val="1300"/>
               </a:spcAft>
               <a:defRPr sz="1800">
                 <a:solidFill>
@@ -5408,7 +5622,7 @@
           <a:p>
             <a:pPr>
               <a:spcAft>
-                <a:spcPts val="1400"/>
+                <a:spcPts val="1300"/>
               </a:spcAft>
               <a:defRPr sz="1800">
                 <a:solidFill>
@@ -5424,7 +5638,7 @@
           <a:p>
             <a:pPr>
               <a:spcAft>
-                <a:spcPts val="1400"/>
+                <a:spcPts val="1300"/>
               </a:spcAft>
               <a:defRPr sz="1800">
                 <a:solidFill>
@@ -5587,8 +5801,8 @@
         </p:nvSpPr>
         <p:spPr>
           <a:xfrm>
-            <a:off x="731520" y="1417320"/>
-            <a:ext cx="10698480" cy="685800"/>
+            <a:off x="731520" y="1371600"/>
+            <a:ext cx="10698480" cy="640080"/>
           </a:xfrm>
           <a:prstGeom prst="rect">
             <a:avLst/>
@@ -5602,7 +5816,7 @@
           <a:lstStyle/>
           <a:p>
             <a:pPr>
-              <a:defRPr sz="1800">
+              <a:defRPr sz="1750">
                 <a:solidFill>
                   <a:srgbClr val="64748B"/>
                 </a:solidFill>
@@ -5623,8 +5837,8 @@
         </p:nvSpPr>
         <p:spPr>
           <a:xfrm>
-            <a:off x="731520" y="2148840"/>
-            <a:ext cx="10698480" cy="4114800"/>
+            <a:off x="731520" y="2084831"/>
+            <a:ext cx="6263640" cy="4224528"/>
           </a:xfrm>
           <a:prstGeom prst="roundRect">
             <a:avLst>
@@ -5670,8 +5884,8 @@
         </p:nvSpPr>
         <p:spPr>
           <a:xfrm>
-            <a:off x="1005840" y="2377440"/>
-            <a:ext cx="10149840" cy="3657600"/>
+            <a:off x="960120" y="2267712"/>
+            <a:ext cx="5806440" cy="3886200"/>
           </a:xfrm>
           <a:prstGeom prst="rect">
             <a:avLst/>
@@ -5686,9 +5900,9 @@
           <a:p>
             <a:pPr>
               <a:spcAft>
-                <a:spcPts val="1400"/>
+                <a:spcPts val="1300"/>
               </a:spcAft>
-              <a:defRPr sz="1800">
+              <a:defRPr sz="1750">
                 <a:solidFill>
                   <a:srgbClr val="1E293B"/>
                 </a:solidFill>
@@ -5702,9 +5916,9 @@
           <a:p>
             <a:pPr>
               <a:spcAft>
-                <a:spcPts val="1400"/>
+                <a:spcPts val="1300"/>
               </a:spcAft>
-              <a:defRPr sz="1800">
+              <a:defRPr sz="1750">
                 <a:solidFill>
                   <a:srgbClr val="1E293B"/>
                 </a:solidFill>
@@ -5718,9 +5932,9 @@
           <a:p>
             <a:pPr>
               <a:spcAft>
-                <a:spcPts val="1400"/>
+                <a:spcPts val="1300"/>
               </a:spcAft>
-              <a:defRPr sz="1800">
+              <a:defRPr sz="1750">
                 <a:solidFill>
                   <a:srgbClr val="1E293B"/>
                 </a:solidFill>
@@ -5734,9 +5948,9 @@
           <a:p>
             <a:pPr>
               <a:spcAft>
-                <a:spcPts val="1400"/>
+                <a:spcPts val="1300"/>
               </a:spcAft>
-              <a:defRPr sz="1800">
+              <a:defRPr sz="1750">
                 <a:solidFill>
                   <a:srgbClr val="1E293B"/>
                 </a:solidFill>
@@ -5745,6 +5959,113 @@
             </a:pPr>
             <a:r>
               <a:t>•  Rəqəmsal Sənəd Dövriyyəsi (RSD) — dövlət qurumları arasında sənədlərin kağızsız, birbaşa elektron şəkildə göndərilməsini təmin edən sistemdir.</a:t>
+            </a:r>
+          </a:p>
+        </p:txBody>
+      </p:sp>
+      <p:sp>
+        <p:nvSpPr>
+          <p:cNvPr id="8" name="Rounded Rectangle 7"/>
+          <p:cNvSpPr/>
+          <p:nvPr/>
+        </p:nvSpPr>
+        <p:spPr>
+          <a:xfrm>
+            <a:off x="7223760" y="2084831"/>
+            <a:ext cx="4206240" cy="4224528"/>
+          </a:xfrm>
+          <a:prstGeom prst="roundRect">
+            <a:avLst>
+              <a:gd name="adj" fmla="val 2000"/>
+            </a:avLst>
+          </a:prstGeom>
+          <a:solidFill>
+            <a:srgbClr val="F8FAFC"/>
+          </a:solidFill>
+          <a:ln>
+            <a:solidFill>
+              <a:srgbClr val="CBD5E1"/>
+            </a:solidFill>
+          </a:ln>
+        </p:spPr>
+        <p:style>
+          <a:lnRef idx="1">
+            <a:schemeClr val="accent1"/>
+          </a:lnRef>
+          <a:fillRef idx="3">
+            <a:schemeClr val="accent1"/>
+          </a:fillRef>
+          <a:effectRef idx="2">
+            <a:schemeClr val="accent1"/>
+          </a:effectRef>
+          <a:fontRef idx="minor">
+            <a:schemeClr val="lt1"/>
+          </a:fontRef>
+        </p:style>
+        <p:txBody>
+          <a:bodyPr rtlCol="0" anchor="ctr"/>
+          <a:lstStyle/>
+          <a:p>
+            <a:pPr algn="ctr"/>
+          </a:p>
+        </p:txBody>
+      </p:sp>
+      <p:pic>
+        <p:nvPicPr>
+          <p:cNvPr id="9" name="Picture 8" descr="slide7_elektron_imza_1790802778720.jpg"/>
+          <p:cNvPicPr>
+            <a:picLocks noChangeAspect="1"/>
+          </p:cNvPicPr>
+          <p:nvPr/>
+        </p:nvPicPr>
+        <p:blipFill>
+          <a:blip r:embed="rId2"/>
+          <a:stretch>
+            <a:fillRect/>
+          </a:stretch>
+        </p:blipFill>
+        <p:spPr>
+          <a:xfrm>
+            <a:off x="7360920" y="2240280"/>
+            <a:ext cx="3931920" cy="2935834"/>
+          </a:xfrm>
+          <a:prstGeom prst="rect">
+            <a:avLst/>
+          </a:prstGeom>
+        </p:spPr>
+      </p:pic>
+      <p:sp>
+        <p:nvSpPr>
+          <p:cNvPr id="10" name="TextBox 9"/>
+          <p:cNvSpPr txBox="1"/>
+          <p:nvPr/>
+        </p:nvSpPr>
+        <p:spPr>
+          <a:xfrm>
+            <a:off x="7360920" y="5321808"/>
+            <a:ext cx="3931920" cy="731520"/>
+          </a:xfrm>
+          <a:prstGeom prst="rect">
+            <a:avLst/>
+          </a:prstGeom>
+          <a:noFill/>
+        </p:spPr>
+        <p:txBody>
+          <a:bodyPr wrap="square">
+            <a:spAutoFit/>
+          </a:bodyPr>
+          <a:lstStyle/>
+          <a:p>
+            <a:pPr algn="ctr">
+              <a:defRPr sz="1400" i="1">
+                <a:solidFill>
+                  <a:srgbClr val="64748B"/>
+                </a:solidFill>
+                <a:latin typeface="Calibri"/>
+              </a:defRPr>
+            </a:pPr>
+            <a:r>
+              <a:t>Mobil tətbiq və e-imza ilə sənədin təsdiqi</a:t>
             </a:r>
           </a:p>
         </p:txBody>
@@ -5897,8 +6218,8 @@
         </p:nvSpPr>
         <p:spPr>
           <a:xfrm>
-            <a:off x="731520" y="1417320"/>
-            <a:ext cx="10698480" cy="685800"/>
+            <a:off x="731520" y="1371600"/>
+            <a:ext cx="10698480" cy="640080"/>
           </a:xfrm>
           <a:prstGeom prst="rect">
             <a:avLst/>
@@ -5912,7 +6233,7 @@
           <a:lstStyle/>
           <a:p>
             <a:pPr>
-              <a:defRPr sz="1800">
+              <a:defRPr sz="1750">
                 <a:solidFill>
                   <a:srgbClr val="64748B"/>
                 </a:solidFill>
@@ -5933,8 +6254,8 @@
         </p:nvSpPr>
         <p:spPr>
           <a:xfrm>
-            <a:off x="731520" y="2148840"/>
-            <a:ext cx="10698480" cy="4114800"/>
+            <a:off x="731520" y="2084831"/>
+            <a:ext cx="6263640" cy="4224528"/>
           </a:xfrm>
           <a:prstGeom prst="roundRect">
             <a:avLst>
@@ -5980,8 +6301,8 @@
         </p:nvSpPr>
         <p:spPr>
           <a:xfrm>
-            <a:off x="1005840" y="2377440"/>
-            <a:ext cx="10149840" cy="3657600"/>
+            <a:off x="960120" y="2267712"/>
+            <a:ext cx="5806440" cy="3886200"/>
           </a:xfrm>
           <a:prstGeom prst="rect">
             <a:avLst/>
@@ -5996,9 +6317,9 @@
           <a:p>
             <a:pPr>
               <a:spcAft>
-                <a:spcPts val="1400"/>
+                <a:spcPts val="1000"/>
               </a:spcAft>
-              <a:defRPr sz="1800">
+              <a:defRPr sz="1650">
                 <a:solidFill>
                   <a:srgbClr val="1E293B"/>
                 </a:solidFill>
@@ -6012,9 +6333,9 @@
           <a:p>
             <a:pPr>
               <a:spcAft>
-                <a:spcPts val="1400"/>
+                <a:spcPts val="1000"/>
               </a:spcAft>
-              <a:defRPr sz="1800">
+              <a:defRPr sz="1650">
                 <a:solidFill>
                   <a:srgbClr val="1E293B"/>
                 </a:solidFill>
@@ -6028,9 +6349,9 @@
           <a:p>
             <a:pPr>
               <a:spcAft>
-                <a:spcPts val="1400"/>
+                <a:spcPts val="1000"/>
               </a:spcAft>
-              <a:defRPr sz="1800">
+              <a:defRPr sz="1650">
                 <a:solidFill>
                   <a:srgbClr val="1E293B"/>
                 </a:solidFill>
@@ -6044,9 +6365,9 @@
           <a:p>
             <a:pPr>
               <a:spcAft>
-                <a:spcPts val="1400"/>
+                <a:spcPts val="1000"/>
               </a:spcAft>
-              <a:defRPr sz="1800">
+              <a:defRPr sz="1650">
                 <a:solidFill>
                   <a:srgbClr val="1E293B"/>
                 </a:solidFill>
@@ -6060,9 +6381,9 @@
           <a:p>
             <a:pPr>
               <a:spcAft>
-                <a:spcPts val="1400"/>
+                <a:spcPts val="1000"/>
               </a:spcAft>
-              <a:defRPr sz="1800">
+              <a:defRPr sz="1650">
                 <a:solidFill>
                   <a:srgbClr val="1E293B"/>
                 </a:solidFill>
@@ -6071,6 +6392,113 @@
             </a:pPr>
             <a:r>
               <a:t>5. İcraya nəzarət və Arxiv — tapşırıq yerinə yetirildikdən sonra sənəd elektron arxivdə saxlanılır.</a:t>
+            </a:r>
+          </a:p>
+        </p:txBody>
+      </p:sp>
+      <p:sp>
+        <p:nvSpPr>
+          <p:cNvPr id="8" name="Rounded Rectangle 7"/>
+          <p:cNvSpPr/>
+          <p:nvPr/>
+        </p:nvSpPr>
+        <p:spPr>
+          <a:xfrm>
+            <a:off x="7223760" y="2084831"/>
+            <a:ext cx="4206240" cy="4224528"/>
+          </a:xfrm>
+          <a:prstGeom prst="roundRect">
+            <a:avLst>
+              <a:gd name="adj" fmla="val 2000"/>
+            </a:avLst>
+          </a:prstGeom>
+          <a:solidFill>
+            <a:srgbClr val="F8FAFC"/>
+          </a:solidFill>
+          <a:ln>
+            <a:solidFill>
+              <a:srgbClr val="CBD5E1"/>
+            </a:solidFill>
+          </a:ln>
+        </p:spPr>
+        <p:style>
+          <a:lnRef idx="1">
+            <a:schemeClr val="accent1"/>
+          </a:lnRef>
+          <a:fillRef idx="3">
+            <a:schemeClr val="accent1"/>
+          </a:fillRef>
+          <a:effectRef idx="2">
+            <a:schemeClr val="accent1"/>
+          </a:effectRef>
+          <a:fontRef idx="minor">
+            <a:schemeClr val="lt1"/>
+          </a:fontRef>
+        </p:style>
+        <p:txBody>
+          <a:bodyPr rtlCol="0" anchor="ctr"/>
+          <a:lstStyle/>
+          <a:p>
+            <a:pPr algn="ctr"/>
+          </a:p>
+        </p:txBody>
+      </p:sp>
+      <p:pic>
+        <p:nvPicPr>
+          <p:cNvPr id="9" name="Picture 8" descr="slide8_icra_sxemi.png"/>
+          <p:cNvPicPr>
+            <a:picLocks noChangeAspect="1"/>
+          </p:cNvPicPr>
+          <p:nvPr/>
+        </p:nvPicPr>
+        <p:blipFill>
+          <a:blip r:embed="rId2"/>
+          <a:stretch>
+            <a:fillRect/>
+          </a:stretch>
+        </p:blipFill>
+        <p:spPr>
+          <a:xfrm>
+            <a:off x="7360920" y="2240280"/>
+            <a:ext cx="3931920" cy="2948940"/>
+          </a:xfrm>
+          <a:prstGeom prst="rect">
+            <a:avLst/>
+          </a:prstGeom>
+        </p:spPr>
+      </p:pic>
+      <p:sp>
+        <p:nvSpPr>
+          <p:cNvPr id="10" name="TextBox 9"/>
+          <p:cNvSpPr txBox="1"/>
+          <p:nvPr/>
+        </p:nvSpPr>
+        <p:spPr>
+          <a:xfrm>
+            <a:off x="7360920" y="5321808"/>
+            <a:ext cx="3931920" cy="731520"/>
+          </a:xfrm>
+          <a:prstGeom prst="rect">
+            <a:avLst/>
+          </a:prstGeom>
+          <a:noFill/>
+        </p:spPr>
+        <p:txBody>
+          <a:bodyPr wrap="square">
+            <a:spAutoFit/>
+          </a:bodyPr>
+          <a:lstStyle/>
+          <a:p>
+            <a:pPr algn="ctr">
+              <a:defRPr sz="1400" i="1">
+                <a:solidFill>
+                  <a:srgbClr val="64748B"/>
+                </a:solidFill>
+                <a:latin typeface="Calibri"/>
+              </a:defRPr>
+            </a:pPr>
+            <a:r>
+              <a:t>Elektron sənədin 5 mərhələli icra ardıcıllığı</a:t>
             </a:r>
           </a:p>
         </p:txBody>
@@ -6223,8 +6651,8 @@
         </p:nvSpPr>
         <p:spPr>
           <a:xfrm>
-            <a:off x="731520" y="1417320"/>
-            <a:ext cx="10698480" cy="685800"/>
+            <a:off x="731520" y="1371600"/>
+            <a:ext cx="10698480" cy="640080"/>
           </a:xfrm>
           <a:prstGeom prst="rect">
             <a:avLst/>
@@ -6238,7 +6666,7 @@
           <a:lstStyle/>
           <a:p>
             <a:pPr>
-              <a:defRPr sz="1800">
+              <a:defRPr sz="1750">
                 <a:solidFill>
                   <a:srgbClr val="64748B"/>
                 </a:solidFill>
@@ -6259,8 +6687,8 @@
         </p:nvSpPr>
         <p:spPr>
           <a:xfrm>
-            <a:off x="731520" y="2148840"/>
-            <a:ext cx="10698480" cy="4114800"/>
+            <a:off x="731520" y="2084831"/>
+            <a:ext cx="6263640" cy="4224528"/>
           </a:xfrm>
           <a:prstGeom prst="roundRect">
             <a:avLst>
@@ -6306,8 +6734,8 @@
         </p:nvSpPr>
         <p:spPr>
           <a:xfrm>
-            <a:off x="1005840" y="2377440"/>
-            <a:ext cx="10149840" cy="3657600"/>
+            <a:off x="960120" y="2267712"/>
+            <a:ext cx="5806440" cy="3886200"/>
           </a:xfrm>
           <a:prstGeom prst="rect">
             <a:avLst/>
@@ -6322,9 +6750,9 @@
           <a:p>
             <a:pPr>
               <a:spcAft>
-                <a:spcPts val="1400"/>
+                <a:spcPts val="1000"/>
               </a:spcAft>
-              <a:defRPr sz="1800">
+              <a:defRPr sz="1650">
                 <a:solidFill>
                   <a:srgbClr val="1E293B"/>
                 </a:solidFill>
@@ -6338,9 +6766,9 @@
           <a:p>
             <a:pPr>
               <a:spcAft>
-                <a:spcPts val="1400"/>
+                <a:spcPts val="1000"/>
               </a:spcAft>
-              <a:defRPr sz="1800">
+              <a:defRPr sz="1650">
                 <a:solidFill>
                   <a:srgbClr val="1E293B"/>
                 </a:solidFill>
@@ -6354,9 +6782,9 @@
           <a:p>
             <a:pPr>
               <a:spcAft>
-                <a:spcPts val="1400"/>
+                <a:spcPts val="1000"/>
               </a:spcAft>
-              <a:defRPr sz="1800">
+              <a:defRPr sz="1650">
                 <a:solidFill>
                   <a:srgbClr val="1E293B"/>
                 </a:solidFill>
@@ -6370,9 +6798,9 @@
           <a:p>
             <a:pPr>
               <a:spcAft>
-                <a:spcPts val="1400"/>
+                <a:spcPts val="1000"/>
               </a:spcAft>
-              <a:defRPr sz="1800">
+              <a:defRPr sz="1650">
                 <a:solidFill>
                   <a:srgbClr val="1E293B"/>
                 </a:solidFill>
@@ -6386,9 +6814,9 @@
           <a:p>
             <a:pPr>
               <a:spcAft>
-                <a:spcPts val="1400"/>
+                <a:spcPts val="1000"/>
               </a:spcAft>
-              <a:defRPr sz="1800">
+              <a:defRPr sz="1650">
                 <a:solidFill>
                   <a:srgbClr val="1E293B"/>
                 </a:solidFill>
@@ -6397,6 +6825,113 @@
             </a:pPr>
             <a:r>
               <a:t>•  Böyük həcmli fayllar göndərilərkən qarşı tərəfə əvvəlcədən məlumat verilməlidir.</a:t>
+            </a:r>
+          </a:p>
+        </p:txBody>
+      </p:sp>
+      <p:sp>
+        <p:nvSpPr>
+          <p:cNvPr id="8" name="Rounded Rectangle 7"/>
+          <p:cNvSpPr/>
+          <p:nvPr/>
+        </p:nvSpPr>
+        <p:spPr>
+          <a:xfrm>
+            <a:off x="7223760" y="2084831"/>
+            <a:ext cx="4206240" cy="4224528"/>
+          </a:xfrm>
+          <a:prstGeom prst="roundRect">
+            <a:avLst>
+              <a:gd name="adj" fmla="val 2000"/>
+            </a:avLst>
+          </a:prstGeom>
+          <a:solidFill>
+            <a:srgbClr val="F8FAFC"/>
+          </a:solidFill>
+          <a:ln>
+            <a:solidFill>
+              <a:srgbClr val="CBD5E1"/>
+            </a:solidFill>
+          </a:ln>
+        </p:spPr>
+        <p:style>
+          <a:lnRef idx="1">
+            <a:schemeClr val="accent1"/>
+          </a:lnRef>
+          <a:fillRef idx="3">
+            <a:schemeClr val="accent1"/>
+          </a:fillRef>
+          <a:effectRef idx="2">
+            <a:schemeClr val="accent1"/>
+          </a:effectRef>
+          <a:fontRef idx="minor">
+            <a:schemeClr val="lt1"/>
+          </a:fontRef>
+        </p:style>
+        <p:txBody>
+          <a:bodyPr rtlCol="0" anchor="ctr"/>
+          <a:lstStyle/>
+          <a:p>
+            <a:pPr algn="ctr"/>
+          </a:p>
+        </p:txBody>
+      </p:sp>
+      <p:pic>
+        <p:nvPicPr>
+          <p:cNvPr id="9" name="Picture 8" descr="slide9_email_numunesi.png"/>
+          <p:cNvPicPr>
+            <a:picLocks noChangeAspect="1"/>
+          </p:cNvPicPr>
+          <p:nvPr/>
+        </p:nvPicPr>
+        <p:blipFill>
+          <a:blip r:embed="rId2"/>
+          <a:stretch>
+            <a:fillRect/>
+          </a:stretch>
+        </p:blipFill>
+        <p:spPr>
+          <a:xfrm>
+            <a:off x="7360920" y="2240280"/>
+            <a:ext cx="3931920" cy="2948940"/>
+          </a:xfrm>
+          <a:prstGeom prst="rect">
+            <a:avLst/>
+          </a:prstGeom>
+        </p:spPr>
+      </p:pic>
+      <p:sp>
+        <p:nvSpPr>
+          <p:cNvPr id="10" name="TextBox 9"/>
+          <p:cNvSpPr txBox="1"/>
+          <p:nvPr/>
+        </p:nvSpPr>
+        <p:spPr>
+          <a:xfrm>
+            <a:off x="7360920" y="5321808"/>
+            <a:ext cx="3931920" cy="731520"/>
+          </a:xfrm>
+          <a:prstGeom prst="rect">
+            <a:avLst/>
+          </a:prstGeom>
+          <a:noFill/>
+        </p:spPr>
+        <p:txBody>
+          <a:bodyPr wrap="square">
+            <a:spAutoFit/>
+          </a:bodyPr>
+          <a:lstStyle/>
+          <a:p>
+            <a:pPr algn="ctr">
+              <a:defRPr sz="1400" i="1">
+                <a:solidFill>
+                  <a:srgbClr val="64748B"/>
+                </a:solidFill>
+                <a:latin typeface="Calibri"/>
+              </a:defRPr>
+            </a:pPr>
+            <a:r>
+              <a:t>Standartlara uyğun işgüzar e-məktub nümunəsi</a:t>
             </a:r>
           </a:p>
         </p:txBody>

</xml_diff>